<commit_message>
Corregir a 15 pacientes evaluados en las diapositivas potencIA
Co-Authored-By: Claude Fable 5.1 <noreply@anthropic.com>
Claude-Session: https://claude.ai/code/session_01QKUqPtYBw3SehDfCG1ApKu
</commit_message>
<xml_diff>
--- a/proyectos/potencia_presentacion/Cristina_potencIA_sesion2_v2.pptx
+++ b/proyectos/potencia_presentacion/Cristina_potencIA_sesion2_v2.pptx
@@ -685,7 +685,7 @@
             <a:r>
               <a:rPr lang="en-US" dirty="0"/>
               <a:t>BLOQUE 3 · 120 s
-Lo uso en cada consulta desde abril: 30 pacientes, con los datos ya ordenados para un análisis estadístico. El informe con semáforo sale en segundos y me ahorra cerca de 20 minutos por paciente.
+Lo uso en cada consulta desde abril: 15 pacientes, con los datos ya ordenados para un análisis estadístico. El informe con semáforo sale en segundos y me ahorra cerca de 20 minutos por paciente.
 Lo que falló: (1) El código funciona, pero yo no puedo leerlo. Descubrí que no tenía forma de saber si un percentil estaba bien calculado salvo rehaciéndolo a mano. (2) La aplicación estuvo meses abierta en internet sin contraseña: cualquiera con el enlace podía entrar. Lo arreglamos la semana pasada. (3) Las tablas de referencia quedaron metidas dentro del código, sin anotar de qué publicación salen. Si un colega me pregunta la fuente, hoy tengo que buscarla.
 BLOQUE 4 · 60 s
 Repito: la calculadora, y pedirle siempre a la IA el código completo. Descarto: dar por bueno algo porque corre. Me falta: usuarios y contraseña, copias de seguridad, y aprender a revisar un cambio antes de publicarlo.
@@ -2875,7 +2875,7 @@
                 <a:ea typeface="Calibri" pitchFamily="34" charset="-122"/>
                 <a:cs typeface="Calibri" pitchFamily="34" charset="-120"/>
               </a:rPr>
-              <a:t>30 pacientes desde abril. Informe en segundos, con semáforo e interpretación. Datos listos para análisis estadístico.</a:t>
+              <a:t>15 pacientes desde abril. Informe en segundos, con semáforo e interpretación. Datos listos para análisis estadístico.</a:t>
             </a:r>
             <a:endParaRPr lang="en-US" sz="1300" dirty="0"/>
           </a:p>

</xml_diff>